<commit_message>
docs(parte-14): integrar casos reales en controles y auditoria
</commit_message>
<xml_diff>
--- a/classes/parte-14-grc-riesgo-y-cumplimiento/276-gobernanza-de-la-seguridad-de-la-informacion/clase-276-presentacion.pptx
+++ b/classes/parte-14-grc-riesgo-y-cumplimiento/276-gobernanza-de-la-seguridad-de-la-informacion/clase-276-presentacion.pptx
@@ -21,6 +21,7 @@
     <p:sldId id="269" r:id="rId20"/>
     <p:sldId id="270" r:id="rId21"/>
     <p:sldId id="271" r:id="rId22"/>
+    <p:sldId id="272" r:id="rId23"/>
   </p:sldIdLst>
   <p:sldSz cx="9144000" cy="6858000" type="screen4x3"/>
   <p:notesSz cx="6858000" cy="9144000"/>
@@ -3497,6 +3498,21 @@
               <a:t>•  Propón tres indicadores que un comité de seguridad debería revisar en cada reunión.</a:t>
             </a:r>
           </a:p>
+          <a:p>
+            <a:pPr>
+              <a:spcAft>
+                <a:spcPts val="600"/>
+              </a:spcAft>
+            </a:pPr>
+            <a:r>
+              <a:rPr sz="1500">
+                <a:solidFill>
+                  <a:srgbClr val="22282E"/>
+                </a:solidFill>
+              </a:rPr>
+              <a:t>•  Para FTX y Celsius, separa en columnas fuente, estado procesal, hecho o alegación,</a:t>
+            </a:r>
+          </a:p>
         </p:txBody>
       </p:sp>
     </p:spTree>
@@ -3601,6 +3617,36 @@
               <a:t>•  Criterio de aceptación: el charter incluye propósito, composición, cadencia, autoridad de decisión y línea de reporte a la junta; la matriz RACI tiene exactamente un aprobador por actividad y ningún…</a:t>
             </a:r>
           </a:p>
+          <a:p>
+            <a:pPr>
+              <a:spcAft>
+                <a:spcPts val="600"/>
+              </a:spcAft>
+            </a:pPr>
+            <a:r>
+              <a:rPr sz="1500">
+                <a:solidFill>
+                  <a:srgbClr val="22282E"/>
+                </a:solidFill>
+              </a:rPr>
+              <a:t>•  La ampliación de operaciones sensibles debe incluir prueba negativa, caducidad de la excepción,</a:t>
+            </a:r>
+          </a:p>
+          <a:p>
+            <a:pPr>
+              <a:spcAft>
+                <a:spcPts val="600"/>
+              </a:spcAft>
+            </a:pPr>
+            <a:r>
+              <a:rPr sz="1500">
+                <a:solidFill>
+                  <a:srgbClr val="22282E"/>
+                </a:solidFill>
+              </a:rPr>
+              <a:t>•  evidencia de conciliación y una sección explícita sobre lo que la anomalía no permite concluir.</a:t>
+            </a:r>
+          </a:p>
         </p:txBody>
       </p:sp>
     </p:spTree>
@@ -3750,6 +3796,36 @@
               <a:t>•  Directivos no rinden cuentas tras un incidente — Falta due care documentado; registra decisiones y aprobaciones</a:t>
             </a:r>
           </a:p>
+          <a:p>
+            <a:pPr>
+              <a:spcAft>
+                <a:spcPts val="600"/>
+              </a:spcAft>
+            </a:pPr>
+            <a:r>
+              <a:rPr sz="1500">
+                <a:solidFill>
+                  <a:srgbClr val="22282E"/>
+                </a:solidFill>
+              </a:rPr>
+              <a:t>•  Una excepción se vuelve privilegio permanente — No tiene caducidad, alerta o revisión; aplica alcance mínimo y cierre verificable</a:t>
+            </a:r>
+          </a:p>
+          <a:p>
+            <a:pPr>
+              <a:spcAft>
+                <a:spcPts val="600"/>
+              </a:spcAft>
+            </a:pPr>
+            <a:r>
+              <a:rPr sz="1500">
+                <a:solidFill>
+                  <a:srgbClr val="22282E"/>
+                </a:solidFill>
+              </a:rPr>
+              <a:t>•  Un evento se trata como prueba de intención — El registro muestra una acción atribuida a una cuenta, no necesariamente a una persona ni su propósito</a:t>
+            </a:r>
+          </a:p>
         </p:txBody>
       </p:sp>
     </p:spTree>
@@ -4078,6 +4154,36 @@
               <a:t>•  SANS Security Policy Templates. &lt;https://www.sans.org/information-security-policy/&gt;</a:t>
             </a:r>
           </a:p>
+          <a:p>
+            <a:pPr>
+              <a:spcAft>
+                <a:spcPts val="600"/>
+              </a:spcAft>
+            </a:pPr>
+            <a:r>
+              <a:rPr sz="1500">
+                <a:solidFill>
+                  <a:srgbClr val="22282E"/>
+                </a:solidFill>
+              </a:rPr>
+              <a:t>•  U.S. House Committee on Financial Services — testimonio de John J. Ray III sobre FTX; respalda concentración de control, ausencia de gobierno y controles sobre activos (2022).…</a:t>
+            </a:r>
+          </a:p>
+          <a:p>
+            <a:pPr>
+              <a:spcAft>
+                <a:spcPts val="600"/>
+              </a:spcAft>
+            </a:pPr>
+            <a:r>
+              <a:rPr sz="1500">
+                <a:solidFill>
+                  <a:srgbClr val="22282E"/>
+                </a:solidFill>
+              </a:rPr>
+              <a:t>•  FTX Debtors — First Interim Report... on Control Failures at the FTX Exchanges, documento presentado en la causa de quiebra 22-11068-JTD (2023); respalda hallazgos técnicos y de control con las…</a:t>
+            </a:r>
+          </a:p>
         </p:txBody>
       </p:sp>
     </p:spTree>
@@ -4126,7 +4232,7 @@
                   <a:srgbClr val="0B3D2E"/>
                 </a:solidFill>
               </a:rPr>
-              <a:t>Diagrama de la clase</a:t>
+              <a:t>Diagrama 1</a:t>
             </a:r>
           </a:p>
         </p:txBody>
@@ -4163,6 +4269,81 @@
 </p:sld>
 </file>
 
+<file path=ppt/slides/slide17.xml><?xml version="1.0" encoding="utf-8"?>
+<p:sld xmlns:a="http://schemas.openxmlformats.org/drawingml/2006/main" xmlns:p="http://schemas.openxmlformats.org/presentationml/2006/main" xmlns:r="http://schemas.openxmlformats.org/officeDocument/2006/relationships">
+  <p:cSld>
+    <p:spTree>
+      <p:nvGrpSpPr>
+        <p:cNvPr id="1" name=""/>
+        <p:cNvGrpSpPr/>
+        <p:nvPr/>
+      </p:nvGrpSpPr>
+      <p:grpSpPr/>
+      <p:sp>
+        <p:nvSpPr>
+          <p:cNvPr id="2" name="TextBox 1"/>
+          <p:cNvSpPr txBox="1"/>
+          <p:nvPr/>
+        </p:nvSpPr>
+        <p:spPr>
+          <a:xfrm>
+            <a:off x="457200" y="274320"/>
+            <a:ext cx="8229600" cy="640080"/>
+          </a:xfrm>
+          <a:prstGeom prst="rect">
+            <a:avLst/>
+          </a:prstGeom>
+          <a:noFill/>
+        </p:spPr>
+        <p:txBody>
+          <a:bodyPr wrap="square">
+            <a:spAutoFit/>
+          </a:bodyPr>
+          <a:lstStyle/>
+          <a:p>
+            <a:r>
+              <a:rPr sz="2200" b="1">
+                <a:solidFill>
+                  <a:srgbClr val="0B3D2E"/>
+                </a:solidFill>
+              </a:rPr>
+              <a:t>Diagrama 2</a:t>
+            </a:r>
+          </a:p>
+        </p:txBody>
+      </p:sp>
+      <p:pic>
+        <p:nvPicPr>
+          <p:cNvPr id="3" name="Picture 2" descr="9d82f8e2e20eabe9.png"/>
+          <p:cNvPicPr>
+            <a:picLocks noChangeAspect="1"/>
+          </p:cNvPicPr>
+          <p:nvPr/>
+        </p:nvPicPr>
+        <p:blipFill>
+          <a:blip r:embed="rId2"/>
+          <a:stretch>
+            <a:fillRect/>
+          </a:stretch>
+        </p:blipFill>
+        <p:spPr>
+          <a:xfrm>
+            <a:off x="457200" y="3516302"/>
+            <a:ext cx="8229600" cy="465475"/>
+          </a:xfrm>
+          <a:prstGeom prst="rect">
+            <a:avLst/>
+          </a:prstGeom>
+        </p:spPr>
+      </p:pic>
+    </p:spTree>
+  </p:cSld>
+  <p:clrMapOvr>
+    <a:masterClrMapping/>
+  </p:clrMapOvr>
+</p:sld>
+</file>
+
 <file path=ppt/slides/slide2.xml><?xml version="1.0" encoding="utf-8"?>
 <p:sld xmlns:a="http://schemas.openxmlformats.org/drawingml/2006/main" xmlns:p="http://schemas.openxmlformats.org/presentationml/2006/main" xmlns:r="http://schemas.openxmlformats.org/officeDocument/2006/relationships">
   <p:cSld>
@@ -4406,6 +4587,21 @@
               <a:t>•  Redactar el borrador de una carta de gobierno (charter) de un comité de seguridad.</a:t>
             </a:r>
           </a:p>
+          <a:p>
+            <a:pPr>
+              <a:spcAft>
+                <a:spcPts val="600"/>
+              </a:spcAft>
+            </a:pPr>
+            <a:r>
+              <a:rPr sz="1500">
+                <a:solidFill>
+                  <a:srgbClr val="22282E"/>
+                </a:solidFill>
+              </a:rPr>
+              <a:t>•  Evaluar si privilegios, excepciones y registros de aprobación permiten que una persona o grupo concentre solicitud, autorización, ejecución y supervisión.</a:t>
+            </a:r>
+          </a:p>
         </p:txBody>
       </p:sp>
     </p:spTree>
@@ -4689,6 +4885,81 @@
               <a:t>•  Una excepción de MFA permanece abierta porque nadie acepta el riesgo. El CISO documenta exposición y opciones; el dueño de negocio decide dentro de su autoridad y el comité escala si supera apetito.…</a:t>
             </a:r>
           </a:p>
+          <a:p>
+            <a:pPr>
+              <a:spcAft>
+                <a:spcPts val="600"/>
+              </a:spcAft>
+            </a:pPr>
+            <a:r>
+              <a:rPr sz="1500">
+                <a:solidFill>
+                  <a:srgbClr val="22282E"/>
+                </a:solidFill>
+              </a:rPr>
+              <a:t>•  Los casos reales son útiles solo si se conserva el estado de cada fuente. En testimonio oficial ante</a:t>
+            </a:r>
+          </a:p>
+          <a:p>
+            <a:pPr>
+              <a:spcAft>
+                <a:spcPts val="600"/>
+              </a:spcAft>
+            </a:pPr>
+            <a:r>
+              <a:rPr sz="1500">
+                <a:solidFill>
+                  <a:srgbClr val="22282E"/>
+                </a:solidFill>
+              </a:rPr>
+              <a:t>•  el Congreso de Estados Unidos, el nuevo CEO de FTX describió una investigación todavía en curso,</a:t>
+            </a:r>
+          </a:p>
+          <a:p>
+            <a:pPr>
+              <a:spcAft>
+                <a:spcPts val="600"/>
+              </a:spcAft>
+            </a:pPr>
+            <a:r>
+              <a:rPr sz="1500">
+                <a:solidFill>
+                  <a:srgbClr val="22282E"/>
+                </a:solidFill>
+              </a:rPr>
+              <a:t>•  con concentración de control en un grupo pequeño, acceso de alta dirección a sistemas con activos</a:t>
+            </a:r>
+          </a:p>
+          <a:p>
+            <a:pPr>
+              <a:spcAft>
+                <a:spcPts val="600"/>
+              </a:spcAft>
+            </a:pPr>
+            <a:r>
+              <a:rPr sz="1500">
+                <a:solidFill>
+                  <a:srgbClr val="22282E"/>
+                </a:solidFill>
+              </a:rPr>
+              <a:t>•  de clientes sin controles que impidieran redirecciones, mezcla de activos, documentación incompleta</a:t>
+            </a:r>
+          </a:p>
+          <a:p>
+            <a:pPr>
+              <a:spcAft>
+                <a:spcPts val="600"/>
+              </a:spcAft>
+            </a:pPr>
+            <a:r>
+              <a:rPr sz="1500">
+                <a:solidFill>
+                  <a:srgbClr val="22282E"/>
+                </a:solidFill>
+              </a:rPr>
+              <a:t>•  y ausencia de gobierno independiente. El informe interino presentado en la quiebra añadió hallazgos</a:t>
+            </a:r>
+          </a:p>
         </p:txBody>
       </p:sp>
     </p:spTree>
@@ -4821,6 +5092,36 @@
                 </a:solidFill>
               </a:rPr>
               <a:t>•  Assurance — Confianza sustentada en evidencia sobre diseño y operación.</a:t>
+            </a:r>
+          </a:p>
+          <a:p>
+            <a:pPr>
+              <a:spcAft>
+                <a:spcPts val="600"/>
+              </a:spcAft>
+            </a:pPr>
+            <a:r>
+              <a:rPr sz="1500">
+                <a:solidFill>
+                  <a:srgbClr val="22282E"/>
+                </a:solidFill>
+              </a:rPr>
+              <a:t>•  Segregación de funciones — Separación de capacidades incompatibles para que una acción sensible requiera control independiente.</a:t>
+            </a:r>
+          </a:p>
+          <a:p>
+            <a:pPr>
+              <a:spcAft>
+                <a:spcPts val="600"/>
+              </a:spcAft>
+            </a:pPr>
+            <a:r>
+              <a:rPr sz="1500">
+                <a:solidFill>
+                  <a:srgbClr val="22282E"/>
+                </a:solidFill>
+              </a:rPr>
+              <a:t>•  Excepción — Desviación autorizada, acotada, temporal y revisable; no un permiso informal permanente.</a:t>
             </a:r>
           </a:p>
         </p:txBody>

</xml_diff>